<commit_message>
Add ligand efficiency, score-size regression, contact map and site occupancy
New analyses derived from the existing docking output:
- site occupancy against the crystallographic acarbose (scripts/extra_analysis.py)
- ligand efficiency, score-versus-size regression, interaction fingerprint (scripts/fig_extra.py)
- Supplementary_Figures_and_Data.docx/pdf with the full per-compound table
- poster gains the size-bias finding; web page links the supplementary PDF

Co-Authored-By: Claude Opus 5 <noreply@anthropic.com>
</commit_message>
<xml_diff>
--- a/submission/Poster_Puttitada_Pruetchayakul.pptx
+++ b/submission/Poster_Puttitada_Pruetchayakul.pptx
@@ -4763,7 +4763,7 @@
         <p:spPr>
           <a:xfrm>
             <a:off x="2520000" y="14616000"/>
-            <a:ext cx="4579200" cy="3456000"/>
+            <a:ext cx="4579200" cy="3168000"/>
           </a:xfrm>
           <a:prstGeom prst="roundRect">
             <a:avLst>
@@ -4809,7 +4809,7 @@
         <p:spPr>
           <a:xfrm>
             <a:off x="2700000" y="14796000"/>
-            <a:ext cx="4219200" cy="3168000"/>
+            <a:ext cx="4219200" cy="2880000"/>
           </a:xfrm>
           <a:prstGeom prst="rect">
             <a:avLst/>
@@ -4870,7 +4870,7 @@
         <p:spPr>
           <a:xfrm>
             <a:off x="7351200" y="14616000"/>
-            <a:ext cx="4579200" cy="3456000"/>
+            <a:ext cx="4579200" cy="3168000"/>
           </a:xfrm>
           <a:prstGeom prst="roundRect">
             <a:avLst>
@@ -4916,7 +4916,7 @@
         <p:spPr>
           <a:xfrm>
             <a:off x="7531200" y="14796000"/>
-            <a:ext cx="4219200" cy="3168000"/>
+            <a:ext cx="4219200" cy="2880000"/>
           </a:xfrm>
           <a:prstGeom prst="rect">
             <a:avLst/>
@@ -4977,7 +4977,7 @@
         <p:spPr>
           <a:xfrm>
             <a:off x="12182400" y="14616000"/>
-            <a:ext cx="4579200" cy="3456000"/>
+            <a:ext cx="4579200" cy="3168000"/>
           </a:xfrm>
           <a:prstGeom prst="roundRect">
             <a:avLst>
@@ -5023,7 +5023,7 @@
         <p:spPr>
           <a:xfrm>
             <a:off x="12362400" y="14796000"/>
-            <a:ext cx="4219200" cy="3168000"/>
+            <a:ext cx="4219200" cy="2880000"/>
           </a:xfrm>
           <a:prstGeom prst="rect">
             <a:avLst/>
@@ -5084,7 +5084,7 @@
         <p:spPr>
           <a:xfrm>
             <a:off x="17013600" y="14616000"/>
-            <a:ext cx="4579200" cy="3456000"/>
+            <a:ext cx="4579200" cy="3168000"/>
           </a:xfrm>
           <a:prstGeom prst="roundRect">
             <a:avLst>
@@ -5130,7 +5130,7 @@
         <p:spPr>
           <a:xfrm>
             <a:off x="17193600" y="14796000"/>
-            <a:ext cx="4219200" cy="3168000"/>
+            <a:ext cx="4219200" cy="2880000"/>
           </a:xfrm>
           <a:prstGeom prst="rect">
             <a:avLst/>
@@ -5191,7 +5191,7 @@
         <p:spPr>
           <a:xfrm>
             <a:off x="21844800" y="14616000"/>
-            <a:ext cx="4579200" cy="3456000"/>
+            <a:ext cx="4579200" cy="3168000"/>
           </a:xfrm>
           <a:prstGeom prst="roundRect">
             <a:avLst>
@@ -5237,7 +5237,7 @@
         <p:spPr>
           <a:xfrm>
             <a:off x="22024800" y="14796000"/>
-            <a:ext cx="4219200" cy="3168000"/>
+            <a:ext cx="4219200" cy="2880000"/>
           </a:xfrm>
           <a:prstGeom prst="rect">
             <a:avLst/>
@@ -5284,7 +5284,7 @@
                 </a:solidFill>
                 <a:latin typeface="Sarabun"/>
               </a:rPr>
-              <a:t>ΔΔG vs acarbose on each enzyme; contact residues ≤ 4 Å, H-bonds ≤ 3.5 Å, logP, ligand efficiency</a:t>
+              <a:t>ΔΔG vs acarbose; contacts ≤ 4 Å and H-bonds ≤ 3.5 Å per residue; ligand efficiency; score–size regression; logP</a:t>
             </a:r>
           </a:p>
         </p:txBody>
@@ -5297,8 +5297,8 @@
         </p:nvSpPr>
         <p:spPr>
           <a:xfrm>
-            <a:off x="2520000" y="18180000"/>
-            <a:ext cx="23904000" cy="864000"/>
+            <a:off x="2520000" y="17892000"/>
+            <a:ext cx="23904000" cy="792000"/>
           </a:xfrm>
           <a:prstGeom prst="rect">
             <a:avLst/>
@@ -5348,7 +5348,7 @@
         </p:nvSpPr>
         <p:spPr>
           <a:xfrm>
-            <a:off x="2520000" y="18936000"/>
+            <a:off x="2520000" y="18576000"/>
             <a:ext cx="23904000" cy="936000"/>
           </a:xfrm>
           <a:prstGeom prst="roundRect">
@@ -5411,8 +5411,8 @@
         </p:blipFill>
         <p:spPr>
           <a:xfrm>
-            <a:off x="2520000" y="20088000"/>
-            <a:ext cx="10800000" cy="8827826"/>
+            <a:off x="2520000" y="19728000"/>
+            <a:ext cx="10440000" cy="8533565"/>
           </a:xfrm>
           <a:prstGeom prst="rect">
             <a:avLst/>
@@ -5427,8 +5427,8 @@
         </p:nvSpPr>
         <p:spPr>
           <a:xfrm>
-            <a:off x="2520000" y="29088000"/>
-            <a:ext cx="10800000" cy="1007999"/>
+            <a:off x="2520000" y="28332000"/>
+            <a:ext cx="10440000" cy="1007999"/>
           </a:xfrm>
           <a:prstGeom prst="rect">
             <a:avLst/>
@@ -5486,8 +5486,8 @@
         </p:blipFill>
         <p:spPr>
           <a:xfrm>
-            <a:off x="13824000" y="20088000"/>
-            <a:ext cx="6192000" cy="4644000"/>
+            <a:off x="13464000" y="19728000"/>
+            <a:ext cx="6372000" cy="4779000"/>
           </a:xfrm>
           <a:prstGeom prst="rect">
             <a:avLst/>
@@ -5510,8 +5510,8 @@
         </p:blipFill>
         <p:spPr>
           <a:xfrm>
-            <a:off x="20232000" y="20088000"/>
-            <a:ext cx="6192000" cy="4644000"/>
+            <a:off x="20052000" y="19728000"/>
+            <a:ext cx="6372000" cy="4779000"/>
           </a:xfrm>
           <a:prstGeom prst="rect">
             <a:avLst/>
@@ -5526,8 +5526,8 @@
         </p:nvSpPr>
         <p:spPr>
           <a:xfrm>
-            <a:off x="13824000" y="24912000"/>
-            <a:ext cx="12600000" cy="1007999"/>
+            <a:off x="13464000" y="24624000"/>
+            <a:ext cx="12960000" cy="1007999"/>
           </a:xfrm>
           <a:prstGeom prst="rect">
             <a:avLst/>
@@ -5577,8 +5577,8 @@
         </p:nvSpPr>
         <p:spPr>
           <a:xfrm>
-            <a:off x="13824000" y="25956000"/>
-            <a:ext cx="12600000" cy="4104000"/>
+            <a:off x="13464000" y="25704000"/>
+            <a:ext cx="12960000" cy="6336000"/>
           </a:xfrm>
           <a:prstGeom prst="roundRect">
             <a:avLst>
@@ -5625,8 +5625,8 @@
         </p:nvSpPr>
         <p:spPr>
           <a:xfrm>
-            <a:off x="14147999" y="26100000"/>
-            <a:ext cx="11952000" cy="3816000"/>
+            <a:off x="13787999" y="25848000"/>
+            <a:ext cx="12312000" cy="6048000"/>
           </a:xfrm>
           <a:prstGeom prst="rect">
             <a:avLst/>
@@ -5644,7 +5644,7 @@
                 <a:spcPct val="107000"/>
               </a:lnSpc>
               <a:spcAft>
-                <a:spcPts val="1000"/>
+                <a:spcPts val="950"/>
               </a:spcAft>
             </a:pPr>
             <a:r>
@@ -5663,7 +5663,7 @@
                 <a:spcPct val="107000"/>
               </a:lnSpc>
               <a:spcAft>
-                <a:spcPts val="1000"/>
+                <a:spcPts val="950"/>
               </a:spcAft>
             </a:pPr>
             <a:r>
@@ -5682,7 +5682,7 @@
                 <a:spcPct val="107000"/>
               </a:lnSpc>
               <a:spcAft>
-                <a:spcPts val="1000"/>
+                <a:spcPts val="950"/>
               </a:spcAft>
             </a:pPr>
             <a:r>
@@ -5701,7 +5701,7 @@
                 <a:spcPct val="107000"/>
               </a:lnSpc>
               <a:spcAft>
-                <a:spcPts val="1000"/>
+                <a:spcPts val="950"/>
               </a:spcAft>
             </a:pPr>
             <a:r>
@@ -5712,6 +5712,44 @@
                 <a:latin typeface="Sarabun"/>
               </a:rPr>
               <a:t>Cyanidin−3−O−glucoside (−7.71 / −8.09) and peonidin−3−O−glucoside (−7.64 / −8.09) ranked next, hydrogen-bonded the catalytic acids Asp443/Asp542 and Asp197/Glu233, and were the only high-ranking compounds with logP &lt; 0.7.</a:t>
+            </a:r>
+          </a:p>
+          <a:p>
+            <a:pPr algn="l">
+              <a:lnSpc>
+                <a:spcPct val="107000"/>
+              </a:lnSpc>
+              <a:spcAft>
+                <a:spcPts val="950"/>
+              </a:spcAft>
+            </a:pPr>
+            <a:r>
+              <a:rPr sz="3000" b="1" i="0">
+                <a:solidFill>
+                  <a:srgbClr val="1D3A8A"/>
+                </a:solidFill>
+                <a:latin typeface="Sarabun"/>
+              </a:rPr>
+              <a:t>Size inflates the score, so efficiency was scored too</a:t>
+            </a:r>
+          </a:p>
+          <a:p>
+            <a:pPr algn="l">
+              <a:lnSpc>
+                <a:spcPct val="107000"/>
+              </a:lnSpc>
+              <a:spcAft>
+                <a:spcPts val="950"/>
+              </a:spcAft>
+            </a:pPr>
+            <a:r>
+              <a:rPr sz="2500" b="0" i="0">
+                <a:solidFill>
+                  <a:srgbClr val="222633"/>
+                </a:solidFill>
+                <a:latin typeface="Sarabun"/>
+              </a:rPr>
+              <a:t>Across the panel the predicted affinity rose with molecular size (Pearson r = 0.73, p = 0.007 on MGAM; r = 0.88, p = 0.0002 on HPA). Per heavy atom the anthocyanins bind more efficiently than the γ-oryzanol esters (0.24 vs 0.20 kcal/mol/atom on MGAM) and than acarbose (0.14).</a:t>
             </a:r>
           </a:p>
         </p:txBody>
@@ -5724,7 +5762,7 @@
         </p:nvSpPr>
         <p:spPr>
           <a:xfrm>
-            <a:off x="2520000" y="30312000"/>
+            <a:off x="2520000" y="32328000"/>
             <a:ext cx="23904000" cy="936000"/>
           </a:xfrm>
           <a:prstGeom prst="roundRect">
@@ -5779,8 +5817,8 @@
         </p:nvSpPr>
         <p:spPr>
           <a:xfrm>
-            <a:off x="2520000" y="31464000"/>
-            <a:ext cx="7728000" cy="5256000"/>
+            <a:off x="2520000" y="33480000"/>
+            <a:ext cx="7728000" cy="4464000"/>
           </a:xfrm>
           <a:prstGeom prst="roundRect">
             <a:avLst>
@@ -5827,8 +5865,8 @@
         </p:nvSpPr>
         <p:spPr>
           <a:xfrm>
-            <a:off x="2808000" y="31680000"/>
-            <a:ext cx="7152000" cy="4824000"/>
+            <a:off x="2808000" y="33660000"/>
+            <a:ext cx="7152000" cy="4104000"/>
           </a:xfrm>
           <a:prstGeom prst="rect">
             <a:avLst/>
@@ -5944,8 +5982,8 @@
         </p:nvSpPr>
         <p:spPr>
           <a:xfrm>
-            <a:off x="10608000" y="31464000"/>
-            <a:ext cx="7728000" cy="5256000"/>
+            <a:off x="10608000" y="33480000"/>
+            <a:ext cx="7728000" cy="4464000"/>
           </a:xfrm>
           <a:prstGeom prst="roundRect">
             <a:avLst>
@@ -5992,8 +6030,8 @@
         </p:nvSpPr>
         <p:spPr>
           <a:xfrm>
-            <a:off x="10896000" y="31680000"/>
-            <a:ext cx="7152000" cy="4824000"/>
+            <a:off x="10896000" y="33660000"/>
+            <a:ext cx="7152000" cy="4104000"/>
           </a:xfrm>
           <a:prstGeom prst="rect">
             <a:avLst/>
@@ -6118,8 +6156,8 @@
         </p:nvSpPr>
         <p:spPr>
           <a:xfrm>
-            <a:off x="18696000" y="31464000"/>
-            <a:ext cx="7728000" cy="5256000"/>
+            <a:off x="18696000" y="33480000"/>
+            <a:ext cx="7728000" cy="4464000"/>
           </a:xfrm>
           <a:prstGeom prst="roundRect">
             <a:avLst>
@@ -6166,8 +6204,8 @@
         </p:nvSpPr>
         <p:spPr>
           <a:xfrm>
-            <a:off x="18984000" y="31680000"/>
-            <a:ext cx="7152000" cy="4824000"/>
+            <a:off x="18984000" y="33660000"/>
+            <a:ext cx="7152000" cy="4104000"/>
           </a:xfrm>
           <a:prstGeom prst="rect">
             <a:avLst/>
@@ -6283,7 +6321,7 @@
         </p:nvSpPr>
         <p:spPr>
           <a:xfrm>
-            <a:off x="2520000" y="37080000"/>
+            <a:off x="2520000" y="38088000"/>
             <a:ext cx="23904000" cy="936000"/>
           </a:xfrm>
           <a:prstGeom prst="roundRect">
@@ -6338,8 +6376,8 @@
         </p:nvSpPr>
         <p:spPr>
           <a:xfrm>
-            <a:off x="2520000" y="38232000"/>
-            <a:ext cx="19944000" cy="4140000"/>
+            <a:off x="2520000" y="39240000"/>
+            <a:ext cx="20304000" cy="3384000"/>
           </a:xfrm>
           <a:prstGeom prst="rect">
             <a:avLst/>
@@ -6489,8 +6527,8 @@
         </p:blipFill>
         <p:spPr>
           <a:xfrm>
-            <a:off x="23004000" y="38232000"/>
-            <a:ext cx="3420000" cy="3420000"/>
+            <a:off x="23364000" y="39240000"/>
+            <a:ext cx="3060000" cy="3060000"/>
           </a:xfrm>
           <a:prstGeom prst="rect">
             <a:avLst/>
@@ -6505,8 +6543,8 @@
         </p:nvSpPr>
         <p:spPr>
           <a:xfrm>
-            <a:off x="22464000" y="41760000"/>
-            <a:ext cx="4500000" cy="864000"/>
+            <a:off x="22428000" y="42408000"/>
+            <a:ext cx="4068000" cy="720000"/>
           </a:xfrm>
           <a:prstGeom prst="rect">
             <a:avLst/>
@@ -6547,7 +6585,7 @@
         </p:nvSpPr>
         <p:spPr>
           <a:xfrm>
-            <a:off x="2520000" y="42480000"/>
+            <a:off x="2520000" y="43380000"/>
             <a:ext cx="23904000" cy="1152000"/>
           </a:xfrm>
           <a:prstGeom prst="rect">

</xml_diff>

<commit_message>
Rebalance the poster layout and clear the abstract title from the template banner
- poster: Fig. 1 fills the left column with a takeaway panel under it, the
  findings panel carries the size-bias result, and no block overlaps or leaves
  the template's content card
- abstract: two spacer lines so the title clears the banner by 1.15 cm
- the lab plan and lab-access letter stay out of this repo (personal contact details)

Co-Authored-By: Claude Opus 5 <noreply@anthropic.com>
</commit_message>
<xml_diff>
--- a/submission/Poster_Puttitada_Pruetchayakul.pptx
+++ b/submission/Poster_Puttitada_Pruetchayakul.pptx
@@ -5412,7 +5412,7 @@
         <p:spPr>
           <a:xfrm>
             <a:off x="2520000" y="19728000"/>
-            <a:ext cx="10440000" cy="8533565"/>
+            <a:ext cx="11160000" cy="9122087"/>
           </a:xfrm>
           <a:prstGeom prst="rect">
             <a:avLst/>
@@ -5427,8 +5427,8 @@
         </p:nvSpPr>
         <p:spPr>
           <a:xfrm>
-            <a:off x="2520000" y="28332000"/>
-            <a:ext cx="10440000" cy="1007999"/>
+            <a:off x="2520000" y="28944000"/>
+            <a:ext cx="11160000" cy="1224000"/>
           </a:xfrm>
           <a:prstGeom prst="rect">
             <a:avLst/>
@@ -5470,115 +5470,16 @@
           </a:p>
         </p:txBody>
       </p:sp>
-      <p:pic>
-        <p:nvPicPr>
-          <p:cNvPr id="47" name="Picture 46" descr="pose_MGAM_cyanidin_3_O_glucoside.png"/>
-          <p:cNvPicPr>
-            <a:picLocks noChangeAspect="1"/>
-          </p:cNvPicPr>
-          <p:nvPr/>
-        </p:nvPicPr>
-        <p:blipFill>
-          <a:blip r:embed="rId5"/>
-          <a:stretch>
-            <a:fillRect/>
-          </a:stretch>
-        </p:blipFill>
-        <p:spPr>
-          <a:xfrm>
-            <a:off x="13464000" y="19728000"/>
-            <a:ext cx="6372000" cy="4779000"/>
-          </a:xfrm>
-          <a:prstGeom prst="rect">
-            <a:avLst/>
-          </a:prstGeom>
-        </p:spPr>
-      </p:pic>
-      <p:pic>
-        <p:nvPicPr>
-          <p:cNvPr id="48" name="Picture 47" descr="pose_HPA_cyanidin_3_O_glucoside.png"/>
-          <p:cNvPicPr>
-            <a:picLocks noChangeAspect="1"/>
-          </p:cNvPicPr>
-          <p:nvPr/>
-        </p:nvPicPr>
-        <p:blipFill>
-          <a:blip r:embed="rId6"/>
-          <a:stretch>
-            <a:fillRect/>
-          </a:stretch>
-        </p:blipFill>
-        <p:spPr>
-          <a:xfrm>
-            <a:off x="20052000" y="19728000"/>
-            <a:ext cx="6372000" cy="4779000"/>
-          </a:xfrm>
-          <a:prstGeom prst="rect">
-            <a:avLst/>
-          </a:prstGeom>
-        </p:spPr>
-      </p:pic>
-      <p:sp>
-        <p:nvSpPr>
-          <p:cNvPr id="49" name="TextBox 48"/>
-          <p:cNvSpPr txBox="1"/>
-          <p:nvPr/>
-        </p:nvSpPr>
-        <p:spPr>
-          <a:xfrm>
-            <a:off x="13464000" y="24624000"/>
-            <a:ext cx="12960000" cy="1007999"/>
-          </a:xfrm>
-          <a:prstGeom prst="rect">
-            <a:avLst/>
-          </a:prstGeom>
-          <a:noFill/>
-        </p:spPr>
-        <p:txBody>
-          <a:bodyPr wrap="square" anchor="t" lIns="72000" rIns="72000" tIns="72000" bIns="72000">
-            <a:spAutoFit/>
-          </a:bodyPr>
-          <a:lstStyle/>
-          <a:p>
-            <a:pPr algn="l">
-              <a:lnSpc>
-                <a:spcPct val="107000"/>
-              </a:lnSpc>
-              <a:spcAft>
-                <a:spcPts val="1080"/>
-              </a:spcAft>
-            </a:pPr>
-            <a:r>
-              <a:rPr sz="2400" b="1" i="0">
-                <a:solidFill>
-                  <a:srgbClr val="222633"/>
-                </a:solidFill>
-                <a:latin typeface="Sarabun"/>
-              </a:rPr>
-              <a:t>Fig. 2 </a:t>
-            </a:r>
-            <a:r>
-              <a:rPr sz="2400" b="0" i="0">
-                <a:solidFill>
-                  <a:srgbClr val="222633"/>
-                </a:solidFill>
-                <a:latin typeface="Sarabun"/>
-              </a:rPr>
-              <a:t>Cyanidin-3-O-glucoside (purple) in α-glucosidase (left) and α-amylase (right). Gold = catalytic residues, green = hydrogen-bond partners.</a:t>
-            </a:r>
-          </a:p>
-        </p:txBody>
-      </p:sp>
-      <p:sp>
-        <p:nvSpPr>
-          <p:cNvPr id="50" name="Rounded Rectangle 49"/>
+      <p:sp>
+        <p:nvSpPr>
+          <p:cNvPr id="47" name="Rounded Rectangle 46"/>
           <p:cNvSpPr/>
           <p:nvPr/>
         </p:nvSpPr>
         <p:spPr>
           <a:xfrm>
-            <a:off x="13464000" y="25704000"/>
-            <a:ext cx="12960000" cy="6336000"/>
+            <a:off x="2520000" y="30312000"/>
+            <a:ext cx="11160000" cy="1655999"/>
           </a:xfrm>
           <a:prstGeom prst="roundRect">
             <a:avLst>
@@ -5619,14 +5520,14 @@
       </p:sp>
       <p:sp>
         <p:nvSpPr>
-          <p:cNvPr id="51" name="TextBox 50"/>
+          <p:cNvPr id="48" name="TextBox 47"/>
           <p:cNvSpPr txBox="1"/>
           <p:nvPr/>
         </p:nvSpPr>
         <p:spPr>
           <a:xfrm>
-            <a:off x="13787999" y="25848000"/>
-            <a:ext cx="12312000" cy="6048000"/>
+            <a:off x="2844000" y="30492000"/>
+            <a:ext cx="10512000" cy="1368000"/>
           </a:xfrm>
           <a:prstGeom prst="rect">
             <a:avLst/>
@@ -5644,112 +5545,116 @@
                 <a:spcPct val="107000"/>
               </a:lnSpc>
               <a:spcAft>
-                <a:spcPts val="950"/>
+                <a:spcPts val="1170"/>
               </a:spcAft>
             </a:pPr>
             <a:r>
-              <a:rPr sz="3000" b="1" i="0">
-                <a:solidFill>
-                  <a:srgbClr val="C28A00"/>
-                </a:solidFill>
-                <a:latin typeface="Sarabun"/>
-              </a:rPr>
-              <a:t>The tightest binder is not the usable one</a:t>
-            </a:r>
-          </a:p>
+              <a:rPr sz="2700" b="1" i="0">
+                <a:solidFill>
+                  <a:srgbClr val="7A3FD1"/>
+                </a:solidFill>
+                <a:latin typeface="Sarabun"/>
+              </a:rPr>
+              <a:t>Only the anthocyanins fall in the shaded region: as good as acarbose on α-glucosidase, milder on α-amylase, and soluble in water.</a:t>
+            </a:r>
+          </a:p>
+        </p:txBody>
+      </p:sp>
+      <p:pic>
+        <p:nvPicPr>
+          <p:cNvPr id="49" name="Picture 48" descr="pose_MGAM_cyanidin_3_O_glucoside.png"/>
+          <p:cNvPicPr>
+            <a:picLocks noChangeAspect="1"/>
+          </p:cNvPicPr>
+          <p:nvPr/>
+        </p:nvPicPr>
+        <p:blipFill>
+          <a:blip r:embed="rId5"/>
+          <a:stretch>
+            <a:fillRect/>
+          </a:stretch>
+        </p:blipFill>
+        <p:spPr>
+          <a:xfrm>
+            <a:off x="14184000" y="19728000"/>
+            <a:ext cx="6012000" cy="4509000"/>
+          </a:xfrm>
+          <a:prstGeom prst="rect">
+            <a:avLst/>
+          </a:prstGeom>
+        </p:spPr>
+      </p:pic>
+      <p:pic>
+        <p:nvPicPr>
+          <p:cNvPr id="50" name="Picture 49" descr="pose_HPA_cyanidin_3_O_glucoside.png"/>
+          <p:cNvPicPr>
+            <a:picLocks noChangeAspect="1"/>
+          </p:cNvPicPr>
+          <p:nvPr/>
+        </p:nvPicPr>
+        <p:blipFill>
+          <a:blip r:embed="rId6"/>
+          <a:stretch>
+            <a:fillRect/>
+          </a:stretch>
+        </p:blipFill>
+        <p:spPr>
+          <a:xfrm>
+            <a:off x="20412000" y="19728000"/>
+            <a:ext cx="6012000" cy="4509000"/>
+          </a:xfrm>
+          <a:prstGeom prst="rect">
+            <a:avLst/>
+          </a:prstGeom>
+        </p:spPr>
+      </p:pic>
+      <p:sp>
+        <p:nvSpPr>
+          <p:cNvPr id="51" name="TextBox 50"/>
+          <p:cNvSpPr txBox="1"/>
+          <p:nvPr/>
+        </p:nvSpPr>
+        <p:spPr>
+          <a:xfrm>
+            <a:off x="14184000" y="24516000"/>
+            <a:ext cx="12240000" cy="1007999"/>
+          </a:xfrm>
+          <a:prstGeom prst="rect">
+            <a:avLst/>
+          </a:prstGeom>
+          <a:noFill/>
+        </p:spPr>
+        <p:txBody>
+          <a:bodyPr wrap="square" anchor="t" lIns="72000" rIns="72000" tIns="72000" bIns="72000">
+            <a:spAutoFit/>
+          </a:bodyPr>
+          <a:lstStyle/>
           <a:p>
             <a:pPr algn="l">
               <a:lnSpc>
                 <a:spcPct val="107000"/>
               </a:lnSpc>
               <a:spcAft>
-                <a:spcPts val="950"/>
+                <a:spcPts val="1080"/>
               </a:spcAft>
             </a:pPr>
             <a:r>
-              <a:rPr sz="2500" b="0" i="0">
+              <a:rPr sz="2400" b="1" i="0">
                 <a:solidFill>
                   <a:srgbClr val="222633"/>
                 </a:solidFill>
                 <a:latin typeface="Sarabun"/>
               </a:rPr>
-              <a:t>γ−Oryzanol esters topped the ranking (cycloartenyl ferulate −8.87 / −10.52 kcal/mol), but with logP &gt; 10 they will not dissolve in the gut lumen, and they sit in the bran's oil fraction.</a:t>
-            </a:r>
-          </a:p>
-          <a:p>
-            <a:pPr algn="l">
-              <a:lnSpc>
-                <a:spcPct val="107000"/>
-              </a:lnSpc>
-              <a:spcAft>
-                <a:spcPts val="950"/>
-              </a:spcAft>
-            </a:pPr>
-            <a:r>
-              <a:rPr sz="3000" b="1" i="0">
-                <a:solidFill>
-                  <a:srgbClr val="7A3FD1"/>
-                </a:solidFill>
-                <a:latin typeface="Sarabun"/>
-              </a:rPr>
-              <a:t>Anthocyanins are the only soluble front-runners</a:t>
-            </a:r>
-          </a:p>
-          <a:p>
-            <a:pPr algn="l">
-              <a:lnSpc>
-                <a:spcPct val="107000"/>
-              </a:lnSpc>
-              <a:spcAft>
-                <a:spcPts val="950"/>
-              </a:spcAft>
-            </a:pPr>
-            <a:r>
-              <a:rPr sz="2500" b="0" i="0">
+              <a:t>Fig. 2 </a:t>
+            </a:r>
+            <a:r>
+              <a:rPr sz="2400" b="0" i="0">
                 <a:solidFill>
                   <a:srgbClr val="222633"/>
                 </a:solidFill>
                 <a:latin typeface="Sarabun"/>
               </a:rPr>
-              <a:t>Cyanidin−3−O−glucoside (−7.71 / −8.09) and peonidin−3−O−glucoside (−7.64 / −8.09) ranked next, hydrogen-bonded the catalytic acids Asp443/Asp542 and Asp197/Glu233, and were the only high-ranking compounds with logP &lt; 0.7.</a:t>
-            </a:r>
-          </a:p>
-          <a:p>
-            <a:pPr algn="l">
-              <a:lnSpc>
-                <a:spcPct val="107000"/>
-              </a:lnSpc>
-              <a:spcAft>
-                <a:spcPts val="950"/>
-              </a:spcAft>
-            </a:pPr>
-            <a:r>
-              <a:rPr sz="3000" b="1" i="0">
-                <a:solidFill>
-                  <a:srgbClr val="1D3A8A"/>
-                </a:solidFill>
-                <a:latin typeface="Sarabun"/>
-              </a:rPr>
-              <a:t>Size inflates the score, so efficiency was scored too</a:t>
-            </a:r>
-          </a:p>
-          <a:p>
-            <a:pPr algn="l">
-              <a:lnSpc>
-                <a:spcPct val="107000"/>
-              </a:lnSpc>
-              <a:spcAft>
-                <a:spcPts val="950"/>
-              </a:spcAft>
-            </a:pPr>
-            <a:r>
-              <a:rPr sz="2500" b="0" i="0">
-                <a:solidFill>
-                  <a:srgbClr val="222633"/>
-                </a:solidFill>
-                <a:latin typeface="Sarabun"/>
-              </a:rPr>
-              <a:t>Across the panel the predicted affinity rose with molecular size (Pearson r = 0.73, p = 0.007 on MGAM; r = 0.88, p = 0.0002 on HPA). Per heavy atom the anthocyanins bind more efficiently than the γ-oryzanol esters (0.24 vs 0.20 kcal/mol/atom on MGAM) and than acarbose (0.14).</a:t>
+              <a:t>Cyanidin-3-O-glucoside (purple) in α-glucosidase (left) and α-amylase (right). Gold = catalytic residues, green = hydrogen-bond partners.</a:t>
             </a:r>
           </a:p>
         </p:txBody>
@@ -5762,19 +5667,21 @@
         </p:nvSpPr>
         <p:spPr>
           <a:xfrm>
-            <a:off x="2520000" y="32328000"/>
-            <a:ext cx="23904000" cy="936000"/>
+            <a:off x="14184000" y="25596000"/>
+            <a:ext cx="12240000" cy="7056000"/>
           </a:xfrm>
           <a:prstGeom prst="roundRect">
             <a:avLst>
-              <a:gd name="adj" fmla="val 50000"/>
+              <a:gd name="adj" fmla="val 6000"/>
             </a:avLst>
           </a:prstGeom>
           <a:solidFill>
-            <a:srgbClr val="7A3FD1"/>
+            <a:srgbClr val="F4EEFF"/>
           </a:solidFill>
-          <a:ln>
-            <a:noFill/>
+          <a:ln w="25400">
+            <a:solidFill>
+              <a:srgbClr val="7A3FD1"/>
+            </a:solidFill>
           </a:ln>
           <a:effectLst/>
         </p:spPr>
@@ -5793,32 +5700,215 @@
           </a:fontRef>
         </p:style>
         <p:txBody>
-          <a:bodyPr rtlCol="0" anchor="ctr" lIns="360000"/>
+          <a:bodyPr rtlCol="0" anchor="ctr"/>
           <a:lstStyle/>
           <a:p>
             <a:pPr algn="ctr"/>
-            <a:r>
-              <a:rPr sz="4600" b="1">
-                <a:solidFill>
-                  <a:srgbClr val="FFFFFF"/>
-                </a:solidFill>
-                <a:latin typeface="Sarabun"/>
-              </a:rPr>
-              <a:t>FROM SCREEN TO PRODUCT</a:t>
-            </a:r>
-          </a:p>
-        </p:txBody>
-      </p:sp>
-      <p:sp>
-        <p:nvSpPr>
-          <p:cNvPr id="53" name="Rounded Rectangle 52"/>
+          </a:p>
+        </p:txBody>
+      </p:sp>
+      <p:sp>
+        <p:nvSpPr>
+          <p:cNvPr id="53" name="TextBox 52"/>
+          <p:cNvSpPr txBox="1"/>
+          <p:nvPr/>
+        </p:nvSpPr>
+        <p:spPr>
+          <a:xfrm>
+            <a:off x="14507999" y="25740000"/>
+            <a:ext cx="11592000" cy="6768000"/>
+          </a:xfrm>
+          <a:prstGeom prst="rect">
+            <a:avLst/>
+          </a:prstGeom>
+          <a:noFill/>
+        </p:spPr>
+        <p:txBody>
+          <a:bodyPr wrap="square" anchor="t" lIns="72000" rIns="72000" tIns="72000" bIns="72000">
+            <a:spAutoFit/>
+          </a:bodyPr>
+          <a:lstStyle/>
+          <a:p>
+            <a:pPr algn="l">
+              <a:lnSpc>
+                <a:spcPct val="107000"/>
+              </a:lnSpc>
+              <a:spcAft>
+                <a:spcPts val="950"/>
+              </a:spcAft>
+            </a:pPr>
+            <a:r>
+              <a:rPr sz="3000" b="1" i="0">
+                <a:solidFill>
+                  <a:srgbClr val="C28A00"/>
+                </a:solidFill>
+                <a:latin typeface="Sarabun"/>
+              </a:rPr>
+              <a:t>The tightest binder is not the usable one</a:t>
+            </a:r>
+          </a:p>
+          <a:p>
+            <a:pPr algn="l">
+              <a:lnSpc>
+                <a:spcPct val="107000"/>
+              </a:lnSpc>
+              <a:spcAft>
+                <a:spcPts val="950"/>
+              </a:spcAft>
+            </a:pPr>
+            <a:r>
+              <a:rPr sz="2500" b="0" i="0">
+                <a:solidFill>
+                  <a:srgbClr val="222633"/>
+                </a:solidFill>
+                <a:latin typeface="Sarabun"/>
+              </a:rPr>
+              <a:t>γ−Oryzanol esters topped the ranking (cycloartenyl ferulate −8.87 / −10.52 kcal/mol), but with logP &gt; 10 they will not dissolve in the gut lumen, and they sit in the bran's oil fraction.</a:t>
+            </a:r>
+          </a:p>
+          <a:p>
+            <a:pPr algn="l">
+              <a:lnSpc>
+                <a:spcPct val="107000"/>
+              </a:lnSpc>
+              <a:spcAft>
+                <a:spcPts val="950"/>
+              </a:spcAft>
+            </a:pPr>
+            <a:r>
+              <a:rPr sz="3000" b="1" i="0">
+                <a:solidFill>
+                  <a:srgbClr val="7A3FD1"/>
+                </a:solidFill>
+                <a:latin typeface="Sarabun"/>
+              </a:rPr>
+              <a:t>Anthocyanins are the only soluble front-runners</a:t>
+            </a:r>
+          </a:p>
+          <a:p>
+            <a:pPr algn="l">
+              <a:lnSpc>
+                <a:spcPct val="107000"/>
+              </a:lnSpc>
+              <a:spcAft>
+                <a:spcPts val="950"/>
+              </a:spcAft>
+            </a:pPr>
+            <a:r>
+              <a:rPr sz="2500" b="0" i="0">
+                <a:solidFill>
+                  <a:srgbClr val="222633"/>
+                </a:solidFill>
+                <a:latin typeface="Sarabun"/>
+              </a:rPr>
+              <a:t>Cyanidin−3−O−glucoside (−7.71 / −8.09) and peonidin−3−O−glucoside (−7.64 / −8.09) ranked next, hydrogen-bonded the catalytic acids Asp443/Asp542 and Asp197/Glu233, and were the only high-ranking compounds with logP &lt; 0.7.</a:t>
+            </a:r>
+          </a:p>
+          <a:p>
+            <a:pPr algn="l">
+              <a:lnSpc>
+                <a:spcPct val="107000"/>
+              </a:lnSpc>
+              <a:spcAft>
+                <a:spcPts val="950"/>
+              </a:spcAft>
+            </a:pPr>
+            <a:r>
+              <a:rPr sz="3000" b="1" i="0">
+                <a:solidFill>
+                  <a:srgbClr val="1D3A8A"/>
+                </a:solidFill>
+                <a:latin typeface="Sarabun"/>
+              </a:rPr>
+              <a:t>Size inflates the score, so efficiency was scored too</a:t>
+            </a:r>
+          </a:p>
+          <a:p>
+            <a:pPr algn="l">
+              <a:lnSpc>
+                <a:spcPct val="107000"/>
+              </a:lnSpc>
+              <a:spcAft>
+                <a:spcPts val="950"/>
+              </a:spcAft>
+            </a:pPr>
+            <a:r>
+              <a:rPr sz="2500" b="0" i="0">
+                <a:solidFill>
+                  <a:srgbClr val="222633"/>
+                </a:solidFill>
+                <a:latin typeface="Sarabun"/>
+              </a:rPr>
+              <a:t>Across the panel the predicted affinity rose with molecular size (Pearson r = 0.73, p = 0.007 on MGAM; r = 0.88, p = 0.0002 on HPA). Per heavy atom the anthocyanins bind more efficiently than the γ-oryzanol esters (0.24 vs 0.20 kcal/mol/atom on MGAM) and than acarbose (0.14).</a:t>
+            </a:r>
+          </a:p>
+        </p:txBody>
+      </p:sp>
+      <p:sp>
+        <p:nvSpPr>
+          <p:cNvPr id="54" name="Rounded Rectangle 53"/>
           <p:cNvSpPr/>
           <p:nvPr/>
         </p:nvSpPr>
         <p:spPr>
           <a:xfrm>
-            <a:off x="2520000" y="33480000"/>
-            <a:ext cx="7728000" cy="4464000"/>
+            <a:off x="2520000" y="32832000"/>
+            <a:ext cx="23904000" cy="936000"/>
+          </a:xfrm>
+          <a:prstGeom prst="roundRect">
+            <a:avLst>
+              <a:gd name="adj" fmla="val 50000"/>
+            </a:avLst>
+          </a:prstGeom>
+          <a:solidFill>
+            <a:srgbClr val="7A3FD1"/>
+          </a:solidFill>
+          <a:ln>
+            <a:noFill/>
+          </a:ln>
+          <a:effectLst/>
+        </p:spPr>
+        <p:style>
+          <a:lnRef idx="1">
+            <a:schemeClr val="accent1"/>
+          </a:lnRef>
+          <a:fillRef idx="3">
+            <a:schemeClr val="accent1"/>
+          </a:fillRef>
+          <a:effectRef idx="2">
+            <a:schemeClr val="accent1"/>
+          </a:effectRef>
+          <a:fontRef idx="minor">
+            <a:schemeClr val="lt1"/>
+          </a:fontRef>
+        </p:style>
+        <p:txBody>
+          <a:bodyPr rtlCol="0" anchor="ctr" lIns="360000"/>
+          <a:lstStyle/>
+          <a:p>
+            <a:pPr algn="ctr"/>
+            <a:r>
+              <a:rPr sz="4600" b="1">
+                <a:solidFill>
+                  <a:srgbClr val="FFFFFF"/>
+                </a:solidFill>
+                <a:latin typeface="Sarabun"/>
+              </a:rPr>
+              <a:t>FROM SCREEN TO PRODUCT</a:t>
+            </a:r>
+          </a:p>
+        </p:txBody>
+      </p:sp>
+      <p:sp>
+        <p:nvSpPr>
+          <p:cNvPr id="55" name="Rounded Rectangle 54"/>
+          <p:cNvSpPr/>
+          <p:nvPr/>
+        </p:nvSpPr>
+        <p:spPr>
+          <a:xfrm>
+            <a:off x="2520000" y="33984000"/>
+            <a:ext cx="7728000" cy="4176000"/>
           </a:xfrm>
           <a:prstGeom prst="roundRect">
             <a:avLst>
@@ -5859,14 +5949,14 @@
       </p:sp>
       <p:sp>
         <p:nvSpPr>
-          <p:cNvPr id="54" name="TextBox 53"/>
+          <p:cNvPr id="56" name="TextBox 55"/>
           <p:cNvSpPr txBox="1"/>
           <p:nvPr/>
         </p:nvSpPr>
         <p:spPr>
           <a:xfrm>
-            <a:off x="2808000" y="33660000"/>
-            <a:ext cx="7152000" cy="4104000"/>
+            <a:off x="2808000" y="34164000"/>
+            <a:ext cx="7152000" cy="3816000"/>
           </a:xfrm>
           <a:prstGeom prst="rect">
             <a:avLst/>
@@ -5976,14 +6066,14 @@
       </p:sp>
       <p:sp>
         <p:nvSpPr>
-          <p:cNvPr id="55" name="Rounded Rectangle 54"/>
+          <p:cNvPr id="57" name="Rounded Rectangle 56"/>
           <p:cNvSpPr/>
           <p:nvPr/>
         </p:nvSpPr>
         <p:spPr>
           <a:xfrm>
-            <a:off x="10608000" y="33480000"/>
-            <a:ext cx="7728000" cy="4464000"/>
+            <a:off x="10608000" y="33984000"/>
+            <a:ext cx="7728000" cy="4176000"/>
           </a:xfrm>
           <a:prstGeom prst="roundRect">
             <a:avLst>
@@ -6024,14 +6114,14 @@
       </p:sp>
       <p:sp>
         <p:nvSpPr>
-          <p:cNvPr id="56" name="TextBox 55"/>
+          <p:cNvPr id="58" name="TextBox 57"/>
           <p:cNvSpPr txBox="1"/>
           <p:nvPr/>
         </p:nvSpPr>
         <p:spPr>
           <a:xfrm>
-            <a:off x="10896000" y="33660000"/>
-            <a:ext cx="7152000" cy="4104000"/>
+            <a:off x="10896000" y="34164000"/>
+            <a:ext cx="7152000" cy="3816000"/>
           </a:xfrm>
           <a:prstGeom prst="rect">
             <a:avLst/>
@@ -6150,14 +6240,14 @@
       </p:sp>
       <p:sp>
         <p:nvSpPr>
-          <p:cNvPr id="57" name="Rounded Rectangle 56"/>
+          <p:cNvPr id="59" name="Rounded Rectangle 58"/>
           <p:cNvSpPr/>
           <p:nvPr/>
         </p:nvSpPr>
         <p:spPr>
           <a:xfrm>
-            <a:off x="18696000" y="33480000"/>
-            <a:ext cx="7728000" cy="4464000"/>
+            <a:off x="18696000" y="33984000"/>
+            <a:ext cx="7728000" cy="4176000"/>
           </a:xfrm>
           <a:prstGeom prst="roundRect">
             <a:avLst>
@@ -6198,14 +6288,14 @@
       </p:sp>
       <p:sp>
         <p:nvSpPr>
-          <p:cNvPr id="58" name="TextBox 57"/>
+          <p:cNvPr id="60" name="TextBox 59"/>
           <p:cNvSpPr txBox="1"/>
           <p:nvPr/>
         </p:nvSpPr>
         <p:spPr>
           <a:xfrm>
-            <a:off x="18984000" y="33660000"/>
-            <a:ext cx="7152000" cy="4104000"/>
+            <a:off x="18984000" y="34164000"/>
+            <a:ext cx="7152000" cy="3816000"/>
           </a:xfrm>
           <a:prstGeom prst="rect">
             <a:avLst/>
@@ -6315,13 +6405,13 @@
       </p:sp>
       <p:sp>
         <p:nvSpPr>
-          <p:cNvPr id="59" name="Rounded Rectangle 58"/>
+          <p:cNvPr id="61" name="Rounded Rectangle 60"/>
           <p:cNvSpPr/>
           <p:nvPr/>
         </p:nvSpPr>
         <p:spPr>
           <a:xfrm>
-            <a:off x="2520000" y="38088000"/>
+            <a:off x="2520000" y="38304000"/>
             <a:ext cx="23904000" cy="936000"/>
           </a:xfrm>
           <a:prstGeom prst="roundRect">
@@ -6370,14 +6460,14 @@
       </p:sp>
       <p:sp>
         <p:nvSpPr>
-          <p:cNvPr id="60" name="TextBox 59"/>
+          <p:cNvPr id="62" name="TextBox 61"/>
           <p:cNvSpPr txBox="1"/>
           <p:nvPr/>
         </p:nvSpPr>
         <p:spPr>
           <a:xfrm>
-            <a:off x="2520000" y="39240000"/>
-            <a:ext cx="20304000" cy="3384000"/>
+            <a:off x="2520000" y="39456000"/>
+            <a:ext cx="20268000" cy="3816000"/>
           </a:xfrm>
           <a:prstGeom prst="rect">
             <a:avLst/>
@@ -6513,7 +6603,7 @@
       </p:sp>
       <p:pic>
         <p:nvPicPr>
-          <p:cNvPr id="61" name="Picture 60" descr="qr.png"/>
+          <p:cNvPr id="63" name="Picture 62" descr="qr.png"/>
           <p:cNvPicPr>
             <a:picLocks noChangeAspect="1"/>
           </p:cNvPicPr>
@@ -6527,8 +6617,8 @@
         </p:blipFill>
         <p:spPr>
           <a:xfrm>
-            <a:off x="23364000" y="39240000"/>
-            <a:ext cx="3060000" cy="3060000"/>
+            <a:off x="23688000" y="39456000"/>
+            <a:ext cx="2736000" cy="2736000"/>
           </a:xfrm>
           <a:prstGeom prst="rect">
             <a:avLst/>
@@ -6537,14 +6627,14 @@
       </p:pic>
       <p:sp>
         <p:nvSpPr>
-          <p:cNvPr id="62" name="TextBox 61"/>
+          <p:cNvPr id="64" name="TextBox 63"/>
           <p:cNvSpPr txBox="1"/>
           <p:nvPr/>
         </p:nvSpPr>
         <p:spPr>
           <a:xfrm>
-            <a:off x="22428000" y="42408000"/>
-            <a:ext cx="4068000" cy="720000"/>
+            <a:off x="22824000" y="42300000"/>
+            <a:ext cx="3743999" cy="684000"/>
           </a:xfrm>
           <a:prstGeom prst="rect">
             <a:avLst/>
@@ -6566,26 +6656,26 @@
               </a:spcAft>
             </a:pPr>
             <a:r>
-              <a:rPr sz="2300" b="1" i="0">
+              <a:rPr sz="2200" b="1" i="0">
                 <a:solidFill>
                   <a:srgbClr val="1D3A8A"/>
                 </a:solidFill>
                 <a:latin typeface="Sarabun"/>
               </a:rPr>
-              <a:t>Rotate the binding sites in 3D</a:t>
-            </a:r>
-          </a:p>
-        </p:txBody>
-      </p:sp>
-      <p:sp>
-        <p:nvSpPr>
-          <p:cNvPr id="63" name="TextBox 62"/>
+              <a:t>Rotate the poses in 3D</a:t>
+            </a:r>
+          </a:p>
+        </p:txBody>
+      </p:sp>
+      <p:sp>
+        <p:nvSpPr>
+          <p:cNvPr id="65" name="TextBox 64"/>
           <p:cNvSpPr txBox="1"/>
           <p:nvPr/>
         </p:nvSpPr>
         <p:spPr>
           <a:xfrm>
-            <a:off x="2520000" y="43380000"/>
+            <a:off x="2520000" y="43488000"/>
             <a:ext cx="23904000" cy="1152000"/>
           </a:xfrm>
           <a:prstGeom prst="rect">

</xml_diff>